<commit_message>
Update Figure 3 bar chart assets
</commit_message>
<xml_diff>
--- a/downloads/eacr2026/eacr2026_imrd_medical_poster_with_figures.pptx
+++ b/downloads/eacr2026/eacr2026_imrd_medical_poster_with_figures.pptx
@@ -3724,7 +3724,7 @@
                 </a:solidFill>
                 <a:latin typeface="Aptos"/>
               </a:rPr>
-              <a:t>High-dimensional transcriptomic models are often interpreted through a single ranked gene list.</a:t>
+              <a:t>Transcriptomic biomarker studies often compress a high-dimensional model into a single Top-K gene list. This can make the result look more definitive than it is.</a:t>
             </a:r>
           </a:p>
           <a:p>
@@ -3747,7 +3747,7 @@
                 </a:solidFill>
                 <a:latin typeface="Aptos"/>
               </a:rPr>
-              <a:t>This is risky for two reasons: feature selection outside resampling can leak held-out information, and leakage-free rankings can still change across split seeds and folds.</a:t>
+              <a:t>Two risks are especially important: feature selection outside resampling can leak held-out information, and leakage-free rankings can still change when folds or split seeds change because correlated genes compete for similar predictive signal.</a:t>
             </a:r>
           </a:p>
         </p:txBody>
@@ -4058,7 +4058,7 @@
         <p:spPr>
           <a:xfrm>
             <a:off x="960120" y="12755880"/>
-            <a:ext cx="8915400" cy="1965960"/>
+            <a:ext cx="8915400" cy="2011680"/>
           </a:xfrm>
           <a:prstGeom prst="rect">
             <a:avLst/>
@@ -4083,7 +4083,7 @@
                 </a:solidFill>
                 <a:latin typeface="Aptos"/>
               </a:rPr>
-              <a:t>TCGA-BRCA expression matrix: 1218 samples and 20530 genes.</a:t>
+              <a:t>TCGA-BRCA expression matrix: 1218 samples, 20530 genes and seven classification tasks.</a:t>
             </a:r>
           </a:p>
           <a:p>
@@ -4106,30 +4106,7 @@
                 </a:solidFill>
                 <a:latin typeface="Aptos"/>
               </a:rPr>
-              <a:t>Seven tasks: tumour-normal, PAM50 subtype, PAM50 without PAM50 genes, IHC subtype, ER, HER2 and TNBC status.</a:t>
-            </a:r>
-          </a:p>
-          <a:p>
-            <a:pPr algn="l">
-              <a:spcAft>
-                <a:spcPts val="200"/>
-              </a:spcAft>
-            </a:pPr>
-          </a:p>
-          <a:p>
-            <a:pPr algn="l">
-              <a:spcAft>
-                <a:spcPts val="200"/>
-              </a:spcAft>
-            </a:pPr>
-            <a:r>
-              <a:rPr sz="1200" b="0">
-                <a:solidFill>
-                  <a:srgbClr val="545F6C"/>
-                </a:solidFill>
-                <a:latin typeface="Aptos"/>
-              </a:rPr>
-              <a:t>Feature selection was nested inside five-fold cross-validation.</a:t>
+              <a:t>All feature selection was nested inside five-fold cross-validation. Held-out folds were not used for filtering, ranking, scaling or panel construction.</a:t>
             </a:r>
           </a:p>
         </p:txBody>
@@ -4192,7 +4169,7 @@
                 </a:solidFill>
                 <a:latin typeface="Aptos"/>
               </a:rPr>
-              <a:t>Design controls</a:t>
+              <a:t>Pipeline details</a:t>
             </a:r>
           </a:p>
           <a:p>
@@ -4208,7 +4185,7 @@
                 </a:solidFill>
                 <a:latin typeface="Aptos"/>
               </a:rPr>
-              <a:t>1. Ranking occurs inside each training fold.</a:t>
+              <a:t>1. Genes were repeatedly assigned to local batches of 100, 250, 500 or 1000 genes.</a:t>
             </a:r>
           </a:p>
           <a:p>
@@ -4224,7 +4201,7 @@
                 </a:solidFill>
                 <a:latin typeface="Aptos"/>
               </a:rPr>
-              <a:t>2. Random batches create repeated local feature competition.</a:t>
+              <a:t>2. Shallow XGBoost models ranked genes within each training fold.</a:t>
             </a:r>
           </a:p>
           <a:p>
@@ -4240,7 +4217,7 @@
                 </a:solidFill>
                 <a:latin typeface="Aptos"/>
               </a:rPr>
-              <a:t>3. Top100 Jaccard audits high-rank stability.</a:t>
+              <a:t>3. Fold-specific Top2000 panels were retrained and compared with fold-matched full Top2000 panels.</a:t>
             </a:r>
           </a:p>
           <a:p>
@@ -4249,15 +4226,6 @@
                 <a:spcPts val="200"/>
               </a:spcAft>
             </a:pPr>
-            <a:r>
-              <a:rPr sz="1200" b="0">
-                <a:solidFill>
-                  <a:srgbClr val="545F6C"/>
-                </a:solidFill>
-                <a:latin typeface="Aptos"/>
-              </a:rPr>
-              <a:t>4. BRCA/PAM50 genes are interpretation controls only.</a:t>
-            </a:r>
           </a:p>
           <a:p>
             <a:pPr algn="l">
@@ -4272,7 +4240,23 @@
                 </a:solidFill>
                 <a:latin typeface="Aptos"/>
               </a:rPr>
-              <a:t>5. Logistic, elastic-net and METABRIC analyses constrain the claim.</a:t>
+              <a:t>Audit controls</a:t>
+            </a:r>
+          </a:p>
+          <a:p>
+            <a:pPr algn="l">
+              <a:spcAft>
+                <a:spcPts val="200"/>
+              </a:spcAft>
+            </a:pPr>
+            <a:r>
+              <a:rPr sz="1200" b="0">
+                <a:solidFill>
+                  <a:srgbClr val="545F6C"/>
+                </a:solidFill>
+                <a:latin typeface="Aptos"/>
+              </a:rPr>
+              <a:t>Top100 Jaccard measured high-rank reproducibility. BRCA/PAM50 genes were used only as interpretation controls. Logistic, elastic-net and METABRIC analyses constrained model-specific claims.</a:t>
             </a:r>
           </a:p>
         </p:txBody>
@@ -5073,7 +5057,7 @@
                 </a:solidFill>
                 <a:latin typeface="Aptos"/>
               </a:rPr>
-              <a:t>Primary finding</a:t>
+              <a:t>Primary findings</a:t>
             </a:r>
           </a:p>
           <a:p>
@@ -5089,7 +5073,55 @@
                 </a:solidFill>
                 <a:latin typeface="Aptos"/>
               </a:rPr>
-              <a:t>Best small-batch or consensus rankings increased Top100 fold-stability across all seven tasks while retaining internal CV5 performance. Prior-gene recovery supported interpretability, but recovered genes remain candidates for follow-up rather than validated biomarkers.</a:t>
+              <a:t>1. Stability: best small-batch or consensus rankings increased Top100 fold-stability across all seven tasks.</a:t>
+            </a:r>
+          </a:p>
+          <a:p>
+            <a:pPr algn="l">
+              <a:spcAft>
+                <a:spcPts val="200"/>
+              </a:spcAft>
+            </a:pPr>
+            <a:r>
+              <a:rPr sz="1300" b="0">
+                <a:solidFill>
+                  <a:srgbClr val="545F6C"/>
+                </a:solidFill>
+                <a:latin typeface="Aptos"/>
+              </a:rPr>
+              <a:t>2. Performance: internal CV5 performance was retained relative to fold-matched full Top2000 panels.</a:t>
+            </a:r>
+          </a:p>
+          <a:p>
+            <a:pPr algn="l">
+              <a:spcAft>
+                <a:spcPts val="200"/>
+              </a:spcAft>
+            </a:pPr>
+            <a:r>
+              <a:rPr sz="1300" b="0">
+                <a:solidFill>
+                  <a:srgbClr val="545F6C"/>
+                </a:solidFill>
+                <a:latin typeface="Aptos"/>
+              </a:rPr>
+              <a:t>3. Interpretability: prior-gene recovery improved in receptor-status and subtype-related tasks.</a:t>
+            </a:r>
+          </a:p>
+          <a:p>
+            <a:pPr algn="l">
+              <a:spcAft>
+                <a:spcPts val="200"/>
+              </a:spcAft>
+            </a:pPr>
+            <a:r>
+              <a:rPr sz="1300" b="0">
+                <a:solidFill>
+                  <a:srgbClr val="545F6C"/>
+                </a:solidFill>
+                <a:latin typeface="Aptos"/>
+              </a:rPr>
+              <a:t>4. Boundary: recovered genes are candidate signals for follow-up, not validated biomarkers.</a:t>
             </a:r>
           </a:p>
         </p:txBody>
@@ -5239,8 +5271,8 @@
         </p:blipFill>
         <p:spPr>
           <a:xfrm>
-            <a:off x="32644080" y="4193954"/>
-            <a:ext cx="9144000" cy="4459410"/>
+            <a:off x="32644080" y="4533373"/>
+            <a:ext cx="9144000" cy="3780572"/>
           </a:xfrm>
           <a:prstGeom prst="rect">
             <a:avLst/>
@@ -5281,7 +5313,30 @@
                 </a:solidFill>
                 <a:latin typeface="Aptos"/>
               </a:rPr>
-              <a:t>Top30 panels retained task signal under XGBoost, logistic regression and elastic net. METABRIC transfer was evaluated only for label-compatible primary-tumour tasks.</a:t>
+              <a:t>Top30 panels retained task signal under XGBoost, logistic regression and elastic net, indicating that the classification signal was not restricted to one model family.</a:t>
+            </a:r>
+          </a:p>
+          <a:p>
+            <a:pPr algn="l">
+              <a:spcAft>
+                <a:spcPts val="200"/>
+              </a:spcAft>
+            </a:pPr>
+          </a:p>
+          <a:p>
+            <a:pPr algn="l">
+              <a:spcAft>
+                <a:spcPts val="200"/>
+              </a:spcAft>
+            </a:pPr>
+            <a:r>
+              <a:rPr sz="1200" b="0">
+                <a:solidFill>
+                  <a:srgbClr val="545F6C"/>
+                </a:solidFill>
+                <a:latin typeface="Aptos"/>
+              </a:rPr>
+              <a:t>METABRIC transfer was evaluated only for label-compatible primary-tumour tasks and used as external context, not as proof of universal superiority.</a:t>
             </a:r>
           </a:p>
         </p:txBody>
@@ -5417,7 +5472,7 @@
       </p:sp>
       <p:pic>
         <p:nvPicPr>
-          <p:cNvPr id="56" name="Picture 55" descr="prognosis_latest_internal_external_cindex.png"/>
+          <p:cNvPr id="56" name="Picture 55" descr="prognosis_latest_internal_regression_elasticnet_cindex.png"/>
           <p:cNvPicPr>
             <a:picLocks noChangeAspect="1"/>
           </p:cNvPicPr>
@@ -5431,8 +5486,8 @@
         </p:blipFill>
         <p:spPr>
           <a:xfrm>
-            <a:off x="35082611" y="14493240"/>
-            <a:ext cx="4266937" cy="2743200"/>
+            <a:off x="35027180" y="14493240"/>
+            <a:ext cx="4377798" cy="2743200"/>
           </a:xfrm>
           <a:prstGeom prst="rect">
             <a:avLst/>
@@ -5657,7 +5712,7 @@
                 </a:solidFill>
                 <a:latin typeface="Aptos"/>
               </a:rPr>
-              <a:t>Repeated fold-contained screening provides an audit layer for transcriptomic machine-learning studies. It helps distinguish predictive tasks that are accurate from gene rankings that are also reproducible.</a:t>
+              <a:t>Repeated fold-contained screening provides an audit layer for transcriptomic machine-learning studies. It helps distinguish predictive tasks that are accurate from gene rankings that are also reproducible enough to justify biological follow-up.</a:t>
             </a:r>
           </a:p>
           <a:p>
@@ -5696,39 +5751,7 @@
                 </a:solidFill>
                 <a:latin typeface="Aptos"/>
               </a:rPr>
-              <a:t>- Candidate-panel study, not biomarker validation.</a:t>
-            </a:r>
-          </a:p>
-          <a:p>
-            <a:pPr algn="l">
-              <a:spcAft>
-                <a:spcPts val="200"/>
-              </a:spcAft>
-            </a:pPr>
-            <a:r>
-              <a:rPr sz="1200" b="0">
-                <a:solidFill>
-                  <a:srgbClr val="545F6C"/>
-                </a:solidFill>
-                <a:latin typeface="Aptos"/>
-              </a:rPr>
-              <a:t>- METABRIC validation is label-limited.</a:t>
-            </a:r>
-          </a:p>
-          <a:p>
-            <a:pPr algn="l">
-              <a:spcAft>
-                <a:spcPts val="200"/>
-              </a:spcAft>
-            </a:pPr>
-            <a:r>
-              <a:rPr sz="1200" b="0">
-                <a:solidFill>
-                  <a:srgbClr val="545F6C"/>
-                </a:solidFill>
-                <a:latin typeface="Aptos"/>
-              </a:rPr>
-              <a:t>- Recovered genes require biological follow-up.</a:t>
+              <a:t>This is a candidate-panel study, not biomarker validation. METABRIC validation is label-limited, tumour-normal transfer was unavailable, and recovered genes require biological follow-up before mechanistic or clinical claims.</a:t>
             </a:r>
           </a:p>
         </p:txBody>

</xml_diff>